<commit_message>
Presentation: BezProgu logo, screenshots of the current UI
Co-Authored-By: Claude Opus 5.5 <noreply@anthropic.com>
</commit_message>
<xml_diff>
--- a/docs/pitch/BezProgu-prezentacja.pptx
+++ b/docs/pitch/BezProgu-prezentacja.pptx
@@ -116,32 +116,32 @@
   <p:extLst>
     <p:ext uri="{521415D9-36F7-43E2-AB2F-B90AF26B5E84}">
       <p14:sectionLst xmlns:p14="http://schemas.microsoft.com/office/powerpoint/2010/main">
-        <p14:section name="Problem i rozwiązanie" id="{b584fc4c-29cd-3b8c-ce42-745ffc4970b5}">
+        <p14:section name="Problem i rozwiązanie" id="{56a12b18-0d71-92b9-fab5-847bdf7e6150}">
           <p14:sldIdLst>
             <p14:sldId id="256"/>
             <p14:sldId id="257"/>
             <p14:sldId id="258"/>
           </p14:sldIdLst>
         </p14:section>
-        <p14:section name="Demonstracja" id="{1311522e-5588-3eb1-6b7d-f3fcdb8233e4}">
+        <p14:section name="Demonstracja" id="{f743c9b4-40e7-4339-3af7-bc031519f589}">
           <p14:sldIdLst>
             <p14:sldId id="259"/>
             <p14:sldId id="260"/>
           </p14:sldIdLst>
         </p14:section>
-        <p14:section name="Dane i architektura" id="{94b392c5-aea1-9678-6a32-c51cd2a9920e}">
+        <p14:section name="Dane i architektura" id="{85411b1b-23ef-3a89-e7f4-6fdb58308f15}">
           <p14:sldIdLst>
             <p14:sldId id="261"/>
             <p14:sldId id="262"/>
           </p14:sldIdLst>
         </p14:section>
-        <p14:section name="Biznes i wdrożenie" id="{59e5fb1e-4ce6-3a94-272b-a385a2380a38}">
+        <p14:section name="Biznes i wdrożenie" id="{47dee407-6b4e-5df3-59e7-0f272e38a0c7}">
           <p14:sldIdLst>
             <p14:sldId id="263"/>
             <p14:sldId id="264"/>
           </p14:sldIdLst>
         </p14:section>
-        <p14:section name="Podsumowanie" id="{483ec1ee-504c-458e-1ce9-eee942070a92}">
+        <p14:section name="Podsumowanie" id="{3f085c56-9e50-55a2-f524-b71c8ec8383d}">
           <p14:sldIdLst>
             <p14:sldId id="265"/>
           </p14:sldIdLst>
@@ -1512,15 +1512,39 @@
           </a:p>
         </p:txBody>
       </p:sp>
-      <p:sp>
-        <p:nvSpPr>
-          <p:cNvPr id="3" name="Text 0"/>
+      <p:pic>
+        <p:nvPicPr>
+          <p:cNvPr id="3" name="Image 0" descr="Znak BezProgu">    </p:cNvPr>
+          <p:cNvPicPr>
+            <a:picLocks noChangeAspect="1"/>
+          </p:cNvPicPr>
+          <p:nvPr/>
+        </p:nvPicPr>
+        <p:blipFill>
+          <a:blip r:embed="rId1"/>
+          <a:stretch>
+            <a:fillRect/>
+          </a:stretch>
+        </p:blipFill>
+        <p:spPr>
+          <a:xfrm>
+            <a:off x="548640" y="6391656"/>
+            <a:ext cx="198144" cy="292608"/>
+          </a:xfrm>
+          <a:prstGeom prst="rect">
+            <a:avLst/>
+          </a:prstGeom>
+        </p:spPr>
+      </p:pic>
+      <p:sp>
+        <p:nvSpPr>
+          <p:cNvPr id="4" name="Text 0"/>
           <p:cNvSpPr/>
           <p:nvPr/>
         </p:nvSpPr>
         <p:spPr>
           <a:xfrm>
-            <a:off x="548640" y="6400800"/>
+            <a:off x="841248" y="6400800"/>
             <a:ext cx="5486400" cy="274320"/>
           </a:xfrm>
           <a:prstGeom prst="rect">
@@ -2103,14 +2127,65 @@
       </p:sp>
       <p:sp>
         <p:nvSpPr>
-          <p:cNvPr id="3" name="Text 1"/>
+          <p:cNvPr id="3" name="Logo – tło"/>
+          <p:cNvSpPr/>
+          <p:nvPr/>
+        </p:nvSpPr>
+        <p:spPr>
+          <a:xfrm>
+            <a:off x="548640" y="1298448"/>
+            <a:ext cx="2919858" cy="1143000"/>
+          </a:xfrm>
+          <a:prstGeom prst="roundRect">
+            <a:avLst>
+              <a:gd name="adj" fmla="val 18000"/>
+            </a:avLst>
+          </a:prstGeom>
+          <a:solidFill>
+            <a:schemeClr val="bg1"/>
+          </a:solidFill>
+          <a:ln w="12700">
+            <a:solidFill>
+              <a:schemeClr val="bg1"/>
+            </a:solidFill>
+            <a:prstDash val="solid"/>
+          </a:ln>
+        </p:spPr>
+      </p:sp>
+      <p:pic>
+        <p:nvPicPr>
+          <p:cNvPr id="4" name="Logo BezProgu" descr="Logo BezProgu">    </p:cNvPr>
+          <p:cNvPicPr>
+            <a:picLocks noChangeAspect="1"/>
+          </p:cNvPicPr>
+          <p:nvPr/>
+        </p:nvPicPr>
+        <p:blipFill>
+          <a:blip r:embed="rId1"/>
+          <a:stretch>
+            <a:fillRect/>
+          </a:stretch>
+        </p:blipFill>
+        <p:spPr>
+          <a:xfrm>
+            <a:off x="822960" y="1527048"/>
+            <a:ext cx="2371218" cy="685800"/>
+          </a:xfrm>
+          <a:prstGeom prst="rect">
+            <a:avLst/>
+          </a:prstGeom>
+        </p:spPr>
+      </p:pic>
+      <p:sp>
+        <p:nvSpPr>
+          <p:cNvPr id="5" name="Text 2"/>
           <p:cNvSpPr txBox="1"/>
           <p:nvPr/>
         </p:nvSpPr>
         <p:spPr>
           <a:xfrm>
-            <a:off x="548640" y="1325880"/>
-            <a:ext cx="7132320" cy="1097280"/>
+            <a:off x="548640" y="2514600"/>
+            <a:ext cx="7132320" cy="640080"/>
           </a:xfrm>
           <a:prstGeom prst="rect">
             <a:avLst/>
@@ -2126,53 +2201,14 @@
               <a:buNone/>
             </a:pPr>
             <a:r>
-              <a:rPr lang="en-US" sz="6600" b="1" dirty="0">
-                <a:solidFill>
-                  <a:schemeClr val="bg1"/>
+              <a:rPr lang="en-US" sz="3200" b="1" dirty="0">
+                <a:solidFill>
+                  <a:schemeClr val="accent2"/>
                 </a:solidFill>
                 <a:latin typeface="Arial" pitchFamily="34" charset="0"/>
                 <a:ea typeface="Arial" pitchFamily="34" charset="-122"/>
                 <a:cs typeface="Arial" pitchFamily="34" charset="-120"/>
               </a:rPr>
-              <a:t>BezProgu</a:t>
-            </a:r>
-            <a:endParaRPr lang="en-US" sz="6600" dirty="0"/>
-          </a:p>
-        </p:txBody>
-      </p:sp>
-      <p:sp>
-        <p:nvSpPr>
-          <p:cNvPr id="4" name="Text 2"/>
-          <p:cNvSpPr txBox="1"/>
-          <p:nvPr/>
-        </p:nvSpPr>
-        <p:spPr>
-          <a:xfrm>
-            <a:off x="548640" y="2514600"/>
-            <a:ext cx="7132320" cy="640080"/>
-          </a:xfrm>
-          <a:prstGeom prst="rect">
-            <a:avLst/>
-          </a:prstGeom>
-          <a:noFill/>
-          <a:ln/>
-        </p:spPr>
-        <p:txBody>
-          <a:bodyPr wrap="square" lIns="0" tIns="0" rIns="0" bIns="0" rtlCol="0" anchor="ctr"/>
-          <a:lstStyle/>
-          <a:p>
-            <a:pPr indent="0" marL="0">
-              <a:buNone/>
-            </a:pPr>
-            <a:r>
-              <a:rPr lang="en-US" sz="3200" b="1" dirty="0">
-                <a:solidFill>
-                  <a:schemeClr val="accent2"/>
-                </a:solidFill>
-                <a:latin typeface="Arial" pitchFamily="34" charset="0"/>
-                <a:ea typeface="Arial" pitchFamily="34" charset="-122"/>
-                <a:cs typeface="Arial" pitchFamily="34" charset="-120"/>
-              </a:rPr>
               <a:t>Nie »dostępne«. Konkretnie.</a:t>
             </a:r>
             <a:endParaRPr lang="en-US" sz="3200" dirty="0"/>
@@ -2181,7 +2217,7 @@
       </p:sp>
       <p:sp>
         <p:nvSpPr>
-          <p:cNvPr id="5" name="Text 3"/>
+          <p:cNvPr id="6" name="Text 3"/>
           <p:cNvSpPr txBox="1"/>
           <p:nvPr/>
         </p:nvSpPr>
@@ -2217,7 +2253,7 @@
       </p:sp>
       <p:sp>
         <p:nvSpPr>
-          <p:cNvPr id="6" name="Osoby na wózkach – tło"/>
+          <p:cNvPr id="7" name="Osoby na wózkach – tło"/>
           <p:cNvSpPr/>
           <p:nvPr/>
         </p:nvSpPr>
@@ -2242,14 +2278,14 @@
       </p:sp>
       <p:pic>
         <p:nvPicPr>
-          <p:cNvPr id="7" name="Osoby na wózkach" descr="Osoby na wózkach">    </p:cNvPr>
+          <p:cNvPr id="8" name="Osoby na wózkach" descr="Osoby na wózkach">    </p:cNvPr>
           <p:cNvPicPr>
             <a:picLocks noChangeAspect="1"/>
           </p:cNvPicPr>
           <p:nvPr/>
         </p:nvPicPr>
         <p:blipFill>
-          <a:blip r:embed="rId1"/>
+          <a:blip r:embed="rId2"/>
           <a:stretch>
             <a:fillRect/>
           </a:stretch>
@@ -2266,7 +2302,7 @@
       </p:pic>
       <p:sp>
         <p:nvSpPr>
-          <p:cNvPr id="8" name="Text 5"/>
+          <p:cNvPr id="9" name="Text 5"/>
           <p:cNvSpPr txBox="1"/>
           <p:nvPr/>
         </p:nvSpPr>
@@ -2302,7 +2338,7 @@
       </p:sp>
       <p:sp>
         <p:nvSpPr>
-          <p:cNvPr id="9" name="Rodzice z wózkami – tło"/>
+          <p:cNvPr id="10" name="Rodzice z wózkami – tło"/>
           <p:cNvSpPr/>
           <p:nvPr/>
         </p:nvSpPr>
@@ -2327,14 +2363,14 @@
       </p:sp>
       <p:pic>
         <p:nvPicPr>
-          <p:cNvPr id="10" name="Rodzice z wózkami" descr="Rodzice z wózkami">    </p:cNvPr>
+          <p:cNvPr id="11" name="Rodzice z wózkami" descr="Rodzice z wózkami">    </p:cNvPr>
           <p:cNvPicPr>
             <a:picLocks noChangeAspect="1"/>
           </p:cNvPicPr>
           <p:nvPr/>
         </p:nvPicPr>
         <p:blipFill>
-          <a:blip r:embed="rId2"/>
+          <a:blip r:embed="rId3"/>
           <a:stretch>
             <a:fillRect/>
           </a:stretch>
@@ -2351,7 +2387,7 @@
       </p:pic>
       <p:sp>
         <p:nvSpPr>
-          <p:cNvPr id="11" name="Text 7"/>
+          <p:cNvPr id="12" name="Text 7"/>
           <p:cNvSpPr txBox="1"/>
           <p:nvPr/>
         </p:nvSpPr>
@@ -2387,7 +2423,7 @@
       </p:sp>
       <p:sp>
         <p:nvSpPr>
-          <p:cNvPr id="12" name="Karta miejsca Sukiennice – ramka"/>
+          <p:cNvPr id="13" name="Karta miejsca Sukiennice – ramka"/>
           <p:cNvSpPr/>
           <p:nvPr/>
         </p:nvSpPr>
@@ -2421,14 +2457,14 @@
       </p:sp>
       <p:pic>
         <p:nvPicPr>
-          <p:cNvPr id="13" name="Karta miejsca Sukiennice" descr="Zrzut ekranu aplikacji BezProgu: Karta miejsca Sukiennice">    </p:cNvPr>
+          <p:cNvPr id="14" name="Karta miejsca Sukiennice" descr="Zrzut ekranu aplikacji BezProgu: Karta miejsca Sukiennice">    </p:cNvPr>
           <p:cNvPicPr>
             <a:picLocks noChangeAspect="1"/>
           </p:cNvPicPr>
           <p:nvPr/>
         </p:nvPicPr>
         <p:blipFill>
-          <a:blip r:embed="rId3"/>
+          <a:blip r:embed="rId4"/>
           <a:stretch>
             <a:fillRect/>
           </a:stretch>
@@ -2959,14 +2995,65 @@
       </p:sp>
       <p:sp>
         <p:nvSpPr>
-          <p:cNvPr id="13" name="Text 9"/>
+          <p:cNvPr id="13" name="Logo – tło"/>
+          <p:cNvSpPr/>
+          <p:nvPr/>
+        </p:nvSpPr>
+        <p:spPr>
+          <a:xfrm>
+            <a:off x="548640" y="5230368"/>
+            <a:ext cx="2014764" cy="777240"/>
+          </a:xfrm>
+          <a:prstGeom prst="roundRect">
+            <a:avLst>
+              <a:gd name="adj" fmla="val 18000"/>
+            </a:avLst>
+          </a:prstGeom>
+          <a:solidFill>
+            <a:schemeClr val="bg1"/>
+          </a:solidFill>
+          <a:ln w="12700">
+            <a:solidFill>
+              <a:schemeClr val="bg1"/>
+            </a:solidFill>
+            <a:prstDash val="solid"/>
+          </a:ln>
+        </p:spPr>
+      </p:sp>
+      <p:pic>
+        <p:nvPicPr>
+          <p:cNvPr id="14" name="Logo BezProgu" descr="Logo BezProgu">    </p:cNvPr>
+          <p:cNvPicPr>
+            <a:picLocks noChangeAspect="1"/>
+          </p:cNvPicPr>
+          <p:nvPr/>
+        </p:nvPicPr>
+        <p:blipFill>
+          <a:blip r:embed="rId3"/>
+          <a:stretch>
+            <a:fillRect/>
+          </a:stretch>
+        </p:blipFill>
+        <p:spPr>
+          <a:xfrm>
+            <a:off x="749808" y="5385816"/>
+            <a:ext cx="1612428" cy="466344"/>
+          </a:xfrm>
+          <a:prstGeom prst="rect">
+            <a:avLst/>
+          </a:prstGeom>
+        </p:spPr>
+      </p:pic>
+      <p:sp>
+        <p:nvSpPr>
+          <p:cNvPr id="15" name="Text 10"/>
           <p:cNvSpPr txBox="1"/>
           <p:nvPr/>
         </p:nvSpPr>
         <p:spPr>
           <a:xfrm>
-            <a:off x="548640" y="5349240"/>
-            <a:ext cx="3657600" cy="548640"/>
+            <a:off x="2880360" y="5349240"/>
+            <a:ext cx="2743200" cy="548640"/>
           </a:xfrm>
           <a:prstGeom prst="rect">
             <a:avLst/>
@@ -2998,7 +3085,7 @@
       </p:sp>
       <p:sp>
         <p:nvSpPr>
-          <p:cNvPr id="14" name="Text 10"/>
+          <p:cNvPr id="16" name="Text 11"/>
           <p:cNvSpPr txBox="1"/>
           <p:nvPr/>
         </p:nvSpPr>
@@ -10064,7 +10151,7 @@
         <p:spPr>
           <a:xfrm>
             <a:off x="548640" y="1280160"/>
-            <a:ext cx="4114800" cy="5043747"/>
+            <a:ext cx="4114800" cy="5073211"/>
           </a:xfrm>
           <a:prstGeom prst="roundRect">
             <a:avLst>
@@ -10099,7 +10186,7 @@
         <p:spPr>
           <a:xfrm>
             <a:off x="731520" y="1463040"/>
-            <a:ext cx="3749040" cy="4175067"/>
+            <a:ext cx="3749040" cy="4204531"/>
           </a:xfrm>
           <a:prstGeom prst="rect">
             <a:avLst/>
@@ -10114,7 +10201,7 @@
         </p:nvSpPr>
         <p:spPr>
           <a:xfrm>
-            <a:off x="731520" y="5747835"/>
+            <a:off x="731520" y="5777299"/>
             <a:ext cx="3749040" cy="594360"/>
           </a:xfrm>
           <a:prstGeom prst="rect">

</xml_diff>

<commit_message>
Blue BezProgu logo, favicon set, updated presentation
- logo.svg / logo-horizontal.svg / favicon.svg: new blue logo (#01064f,
  #96bbde); horizontal viewBox fixed to the artwork (the Krita export placed
  it outside its own canvas)
- favicon.ico, favicon-32.png, apple-touch-icon.png for browsers without SVG
  favicons; ?v=2 on icon links to drop the cached green icon
- theme colour and presentation (logo, footer marks, screenshots) in blue

Co-Authored-By: Claude Opus 5.5 <noreply@anthropic.com>
</commit_message>
<xml_diff>
--- a/docs/pitch/BezProgu-prezentacja.pptx
+++ b/docs/pitch/BezProgu-prezentacja.pptx
@@ -116,32 +116,32 @@
   <p:extLst>
     <p:ext uri="{521415D9-36F7-43E2-AB2F-B90AF26B5E84}">
       <p14:sectionLst xmlns:p14="http://schemas.microsoft.com/office/powerpoint/2010/main">
-        <p14:section name="Problem i rozwiązanie" id="{56a12b18-0d71-92b9-fab5-847bdf7e6150}">
+        <p14:section name="Problem i rozwiązanie" id="{d0e4e03f-b8d6-5cbe-3448-63c30d3bfc73}">
           <p14:sldIdLst>
             <p14:sldId id="256"/>
             <p14:sldId id="257"/>
             <p14:sldId id="258"/>
           </p14:sldIdLst>
         </p14:section>
-        <p14:section name="Demonstracja" id="{f743c9b4-40e7-4339-3af7-bc031519f589}">
+        <p14:section name="Demonstracja" id="{b95e073d-62bb-5006-e89a-4eedfe247f3a}">
           <p14:sldIdLst>
             <p14:sldId id="259"/>
             <p14:sldId id="260"/>
           </p14:sldIdLst>
         </p14:section>
-        <p14:section name="Dane i architektura" id="{85411b1b-23ef-3a89-e7f4-6fdb58308f15}">
+        <p14:section name="Dane i architektura" id="{41a34c2f-b616-772b-15ed-a7311e8aae66}">
           <p14:sldIdLst>
             <p14:sldId id="261"/>
             <p14:sldId id="262"/>
           </p14:sldIdLst>
         </p14:section>
-        <p14:section name="Biznes i wdrożenie" id="{47dee407-6b4e-5df3-59e7-0f272e38a0c7}">
+        <p14:section name="Biznes i wdrożenie" id="{3794ad39-bfa0-a96e-36d5-c2f59ecbbd25}">
           <p14:sldIdLst>
             <p14:sldId id="263"/>
             <p14:sldId id="264"/>
           </p14:sldIdLst>
         </p14:section>
-        <p14:section name="Podsumowanie" id="{3f085c56-9e50-55a2-f524-b71c8ec8383d}">
+        <p14:section name="Podsumowanie" id="{d803a6b4-fd6c-5373-d4cc-968f75ee8766}">
           <p14:sldIdLst>
             <p14:sldId id="265"/>
           </p14:sldIdLst>
@@ -2134,7 +2134,7 @@
         <p:spPr>
           <a:xfrm>
             <a:off x="548640" y="1298448"/>
-            <a:ext cx="2919858" cy="1143000"/>
+            <a:ext cx="3027317" cy="1143000"/>
           </a:xfrm>
           <a:prstGeom prst="roundRect">
             <a:avLst>
@@ -2169,7 +2169,7 @@
         <p:spPr>
           <a:xfrm>
             <a:off x="822960" y="1527048"/>
-            <a:ext cx="2371218" cy="685800"/>
+            <a:ext cx="2478677" cy="685800"/>
           </a:xfrm>
           <a:prstGeom prst="rect">
             <a:avLst/>
@@ -3002,7 +3002,7 @@
         <p:spPr>
           <a:xfrm>
             <a:off x="548640" y="5230368"/>
-            <a:ext cx="2014764" cy="777240"/>
+            <a:ext cx="2087836" cy="777240"/>
           </a:xfrm>
           <a:prstGeom prst="roundRect">
             <a:avLst>
@@ -3037,7 +3037,7 @@
         <p:spPr>
           <a:xfrm>
             <a:off x="749808" y="5385816"/>
-            <a:ext cx="1612428" cy="466344"/>
+            <a:ext cx="1685500" cy="466344"/>
           </a:xfrm>
           <a:prstGeom prst="rect">
             <a:avLst/>

</xml_diff>